<commit_message>
Apply workshops: Foundation F4 (W01–W06); sort-slide labels for custom categories
Co-Authored-By: Claude Opus 5.5 <noreply@anthropic.com>
Claude-Session: https://claude.ai/code/session_01QWUKnGV7MRCnE8883pixoX
</commit_message>
<xml_diff>
--- a/Foundation_F2/Workshop/F2-W06_Apply_Workshop_L11-L12_Pen_Friend_Application.pptx
+++ b/Foundation_F2/Workshop/F2-W06_Apply_Workshop_L11-L12_Pen_Friend_Application.pptx
@@ -39528,14 +39528,14 @@
               <a:buNone/>
             </a:pPr>
             <a:r>
-              <a:rPr lang="en-US" sz="1000" b="1" spc="150" kern="0" dirty="0">
+              <a:rPr lang="en-US" sz="1000" b="1" spc="300" kern="0" dirty="0">
                 <a:solidFill>
                   <a:srgbClr val="2F6FB0"/>
                 </a:solidFill>
                 <a:latin typeface="Calibri" pitchFamily="34" charset="0"/>
                 <a:cs typeface="Amiri" pitchFamily="2" charset="-78"/>
               </a:rPr>
-              <a:t>PART 1 · STEP 2 · WHICH LESSON? · READ EACH CARD, THEN SORT IT</a:t>
+              <a:t>PART 1 · STEP 2 · SORT IT · READ EACH CARD, THEN SORT IT</a:t>
             </a:r>
             <a:endParaRPr lang="en-US" sz="1000" dirty="0"/>
           </a:p>
@@ -39612,7 +39612,7 @@
                 <a:ea typeface="Amiri" pitchFamily="2" charset="-78"/>
                 <a:cs typeface="Amiri" pitchFamily="2" charset="-78"/>
               </a:rPr>
-              <a:t>مِنْ أَيِّ دَرْسٍ؟</a:t>
+              <a:t>صَنِّفِ البِطَاقَاتِ</a:t>
             </a:r>
             <a:endParaRPr lang="ar-SA" sz="2800" dirty="0"/>
           </a:p>
@@ -40873,7 +40873,7 @@
                 <a:ea typeface="Amiri" pitchFamily="2" charset="-78"/>
                 <a:cs typeface="Amiri" pitchFamily="2" charset="-78"/>
               </a:rPr>
-              <a:t>مِنْ أَيِّ دَرْسٍ؟</a:t>
+              <a:t>صَنِّفِ البِطَاقَاتِ</a:t>
             </a:r>
             <a:endParaRPr lang="ar-SA" sz="2800" dirty="0"/>
           </a:p>

</xml_diff>